<commit_message>
refactor: Aktualisierung der API-Antwort und Bereinigung des Profil-Controllers
- Aktualisierung der Gesundheits-API-Antwort mit festen Versions- und Commit-Werten.
- Bereinigung des Profil-Controllers durch Entfernen überflüssiger Leerzeilen.
- Verbesserung der Fehlerbehandlung und Rückgabe von DTOs im Profil-Service.
- Anpassung der Authentifizierungsmiddleware zur Unterstützung von Testumgebungen mit statischen Benutzerdaten.
- Aktualisierung der Umgebungsvariablen für die API-URL im Entwicklungsumfeld.
</commit_message>
<xml_diff>
--- a/documentation/Mealo_Präsentation.pptx
+++ b/documentation/Mealo_Präsentation.pptx
@@ -274,7 +274,7 @@
             <a:pPr rtl="0"/>
             <a:fld id="{664C4DC0-9876-4E6F-9F41-5927D213A67E}" type="datetime1">
               <a:rPr lang="de-DE" smtClean="0"/>
-              <a:t>30.06.2025</a:t>
+              <a:t>01.07.2025</a:t>
             </a:fld>
             <a:endParaRPr lang="de-DE"/>
           </a:p>
@@ -456,7 +456,7 @@
             <a:pPr rtl="0"/>
             <a:fld id="{2C2EA0FA-C0C7-43B0-9915-13FE01CBAEE6}" type="datetime1">
               <a:rPr lang="de-DE" smtClean="0"/>
-              <a:t>30.06.2025</a:t>
+              <a:t>01.07.2025</a:t>
             </a:fld>
             <a:endParaRPr lang="de-DE"/>
           </a:p>
@@ -14765,53 +14765,6 @@
           <a:chExt cx="0" cy="0"/>
         </a:xfrm>
       </p:grpSpPr>
-      <p:sp>
-        <p:nvSpPr>
-          <p:cNvPr id="2" name="Titel 1">
-            <a:extLst>
-              <a:ext uri="{FF2B5EF4-FFF2-40B4-BE49-F238E27FC236}">
-                <a16:creationId xmlns:a16="http://schemas.microsoft.com/office/drawing/2014/main" id="{51DF3D98-3C30-4CFC-8643-C81E829C8C25}"/>
-              </a:ext>
-            </a:extLst>
-          </p:cNvPr>
-          <p:cNvSpPr>
-            <a:spLocks noGrp="1"/>
-          </p:cNvSpPr>
-          <p:nvPr>
-            <p:ph type="title"/>
-          </p:nvPr>
-        </p:nvSpPr>
-        <p:spPr>
-          <a:xfrm>
-            <a:off x="1167492" y="1371600"/>
-            <a:ext cx="6015946" cy="4438650"/>
-          </a:xfrm>
-        </p:spPr>
-        <p:txBody>
-          <a:bodyPr rtlCol="0" anchor="ctr">
-            <a:normAutofit/>
-          </a:bodyPr>
-          <a:lstStyle>
-            <a:defPPr>
-              <a:defRPr lang="de-DE"/>
-            </a:defPPr>
-          </a:lstStyle>
-          <a:p>
-            <a:r>
-              <a:rPr lang="de-DE" sz="4700" dirty="0" err="1"/>
-              <a:t>Mealo</a:t>
-            </a:r>
-            <a:br>
-              <a:rPr lang="de-DE" sz="4700" dirty="0"/>
-            </a:br>
-            <a:r>
-              <a:rPr lang="de-DE" sz="2400" dirty="0"/>
-              <a:t>Dein smarter Küchenbegleiter</a:t>
-            </a:r>
-            <a:endParaRPr lang="de-DE" sz="4700" dirty="0"/>
-          </a:p>
-        </p:txBody>
-      </p:sp>
       <p:pic>
         <p:nvPicPr>
           <p:cNvPr id="1026" name="Picture 2">
@@ -14828,13 +14781,15 @@
         </p:nvPicPr>
         <p:blipFill>
           <a:blip r:embed="rId3"/>
-          <a:srcRect t="16514" b="16514"/>
-          <a:stretch/>
+          <a:srcRect t="16514" b="12481"/>
+          <a:stretch>
+            <a:fillRect/>
+          </a:stretch>
         </p:blipFill>
         <p:spPr bwMode="auto">
           <a:xfrm>
-            <a:off x="6936550" y="1168400"/>
-            <a:ext cx="4500562" cy="4521200"/>
+            <a:off x="1167492" y="519176"/>
+            <a:ext cx="4500562" cy="4793488"/>
           </a:xfrm>
           <a:prstGeom prst="ellipse">
             <a:avLst/>
@@ -14844,6 +14799,49 @@
           </a:solidFill>
         </p:spPr>
       </p:pic>
+      <p:sp>
+        <p:nvSpPr>
+          <p:cNvPr id="2" name="Titel 1">
+            <a:extLst>
+              <a:ext uri="{FF2B5EF4-FFF2-40B4-BE49-F238E27FC236}">
+                <a16:creationId xmlns:a16="http://schemas.microsoft.com/office/drawing/2014/main" id="{51DF3D98-3C30-4CFC-8643-C81E829C8C25}"/>
+              </a:ext>
+            </a:extLst>
+          </p:cNvPr>
+          <p:cNvSpPr>
+            <a:spLocks noGrp="1"/>
+          </p:cNvSpPr>
+          <p:nvPr>
+            <p:ph type="title"/>
+          </p:nvPr>
+        </p:nvSpPr>
+        <p:spPr>
+          <a:xfrm>
+            <a:off x="1167492" y="1545336"/>
+            <a:ext cx="6015946" cy="4438650"/>
+          </a:xfrm>
+        </p:spPr>
+        <p:txBody>
+          <a:bodyPr rtlCol="0" anchor="ctr">
+            <a:normAutofit/>
+          </a:bodyPr>
+          <a:lstStyle>
+            <a:defPPr>
+              <a:defRPr lang="de-DE"/>
+            </a:defPPr>
+          </a:lstStyle>
+          <a:p>
+            <a:br>
+              <a:rPr lang="de-DE" sz="4700" dirty="0"/>
+            </a:br>
+            <a:r>
+              <a:rPr lang="de-DE" sz="2400" dirty="0"/>
+              <a:t>Dein smarter Küchenbegleiter</a:t>
+            </a:r>
+            <a:endParaRPr lang="de-DE" sz="4700" dirty="0"/>
+          </a:p>
+        </p:txBody>
+      </p:sp>
     </p:spTree>
     <p:extLst>
       <p:ext uri="{BB962C8B-B14F-4D97-AF65-F5344CB8AC3E}">
@@ -15657,7 +15655,7 @@
         </p:nvSpPr>
         <p:spPr>
           <a:xfrm>
-            <a:off x="6299133" y="4684558"/>
+            <a:off x="6291072" y="4652629"/>
             <a:ext cx="3521142" cy="1811492"/>
           </a:xfrm>
           <a:prstGeom prst="roundRect">
@@ -16214,7 +16212,7 @@
         </p:blipFill>
         <p:spPr bwMode="auto">
           <a:xfrm>
-            <a:off x="7691798" y="3145384"/>
+            <a:off x="7691798" y="3143533"/>
             <a:ext cx="1988554" cy="570933"/>
           </a:xfrm>
           <a:prstGeom prst="rect">
@@ -16306,13 +16304,18 @@
         </p:blipFill>
         <p:spPr bwMode="auto">
           <a:xfrm>
-            <a:off x="7050386" y="5294142"/>
-            <a:ext cx="838433" cy="838433"/>
+            <a:off x="6920779" y="5138681"/>
+            <a:ext cx="971341" cy="971341"/>
           </a:xfrm>
-          <a:prstGeom prst="rect">
+          <a:prstGeom prst="ellipse">
             <a:avLst/>
           </a:prstGeom>
-          <a:noFill/>
+          <a:ln>
+            <a:noFill/>
+          </a:ln>
+          <a:effectLst>
+            <a:softEdge rad="112500"/>
+          </a:effectLst>
           <a:extLst>
             <a:ext uri="{909E8E84-426E-40DD-AFC4-6F175D3DCCD1}">
               <a14:hiddenFill xmlns:a14="http://schemas.microsoft.com/office/drawing/2010/main">
@@ -17244,7 +17247,7 @@
         <p:spPr>
           <a:xfrm>
             <a:off x="1158865" y="2017467"/>
-            <a:ext cx="9779182" cy="3917658"/>
+            <a:ext cx="8579495" cy="3917658"/>
           </a:xfrm>
         </p:spPr>
         <p:txBody>
@@ -17329,7 +17332,7 @@
         </p:blipFill>
         <p:spPr>
           <a:xfrm>
-            <a:off x="2653225" y="3460282"/>
+            <a:off x="2653224" y="3828274"/>
             <a:ext cx="1900468" cy="1900468"/>
           </a:xfrm>
           <a:prstGeom prst="ellipse">
@@ -17356,7 +17359,7 @@
         </p:nvSpPr>
         <p:spPr>
           <a:xfrm>
-            <a:off x="2376976" y="5502506"/>
+            <a:off x="2376976" y="5753868"/>
             <a:ext cx="2452965" cy="3403537"/>
           </a:xfrm>
           <a:prstGeom prst="rect">
@@ -17566,7 +17569,7 @@
         </p:blipFill>
         <p:spPr>
           <a:xfrm>
-            <a:off x="5098211" y="3429000"/>
+            <a:off x="5146157" y="3828274"/>
             <a:ext cx="1899683" cy="1901270"/>
           </a:xfrm>
           <a:prstGeom prst="ellipse">
@@ -17590,7 +17593,7 @@
         </p:nvSpPr>
         <p:spPr>
           <a:xfrm>
-            <a:off x="4869517" y="5572610"/>
+            <a:off x="4869517" y="5753868"/>
             <a:ext cx="2452965" cy="3403537"/>
           </a:xfrm>
           <a:prstGeom prst="rect">
@@ -18873,7 +18876,7 @@
         <p:spPr>
           <a:xfrm>
             <a:off x="1158865" y="2017467"/>
-            <a:ext cx="9779182" cy="3917658"/>
+            <a:ext cx="8332607" cy="3917658"/>
           </a:xfrm>
         </p:spPr>
         <p:txBody>
@@ -19971,6 +19974,14 @@
 </file>
 
 <file path=customXml/item1.xml><?xml version="1.0" encoding="utf-8"?>
+<p:properties xmlns:p="http://schemas.microsoft.com/office/2006/metadata/properties" xmlns:xsi="http://www.w3.org/2001/XMLSchema-instance" xmlns:pc="http://schemas.microsoft.com/office/infopath/2007/PartnerControls">
+  <documentManagement>
+    <_activity xmlns="b7af3e86-f9f2-49b9-954a-ad5c33749f37" xsi:nil="true"/>
+  </documentManagement>
+</p:properties>
+</file>
+
+<file path=customXml/item2.xml><?xml version="1.0" encoding="utf-8"?>
 <?mso-contentType ?>
 <FormTemplates xmlns="http://schemas.microsoft.com/sharepoint/v3/contenttype/forms">
   <Display>DocumentLibraryForm</Display>
@@ -19979,7 +19990,7 @@
 </FormTemplates>
 </file>
 
-<file path=customXml/item2.xml><?xml version="1.0" encoding="utf-8"?>
+<file path=customXml/item3.xml><?xml version="1.0" encoding="utf-8"?>
 <ct:contentTypeSchema xmlns:ct="http://schemas.microsoft.com/office/2006/metadata/contentType" xmlns:ma="http://schemas.microsoft.com/office/2006/metadata/properties/metaAttributes" ct:_="" ma:_="" ma:contentTypeName="Dokument" ma:contentTypeID="0x010100BC9111FB9E78DE45818A7A2ABBF8EDF5" ma:contentTypeVersion="6" ma:contentTypeDescription="Ein neues Dokument erstellen." ma:contentTypeScope="" ma:versionID="c45bf96cc1af40af3c8a90091e27dc3e">
   <xsd:schema xmlns:xsd="http://www.w3.org/2001/XMLSchema" xmlns:xs="http://www.w3.org/2001/XMLSchema" xmlns:p="http://schemas.microsoft.com/office/2006/metadata/properties" xmlns:ns3="b7af3e86-f9f2-49b9-954a-ad5c33749f37" targetNamespace="http://schemas.microsoft.com/office/2006/metadata/properties" ma:root="true" ma:fieldsID="0ffa99b0f2f1e6187cfe49a1cd52875f" ns3:_="">
     <xsd:import namespace="b7af3e86-f9f2-49b9-954a-ad5c33749f37"/>
@@ -20135,15 +20146,23 @@
 </ct:contentTypeSchema>
 </file>
 
-<file path=customXml/item3.xml><?xml version="1.0" encoding="utf-8"?>
-<p:properties xmlns:p="http://schemas.microsoft.com/office/2006/metadata/properties" xmlns:xsi="http://www.w3.org/2001/XMLSchema-instance" xmlns:pc="http://schemas.microsoft.com/office/infopath/2007/PartnerControls">
-  <documentManagement>
-    <_activity xmlns="b7af3e86-f9f2-49b9-954a-ad5c33749f37" xsi:nil="true"/>
-  </documentManagement>
-</p:properties>
+<file path=customXml/itemProps1.xml><?xml version="1.0" encoding="utf-8"?>
+<ds:datastoreItem xmlns:ds="http://schemas.openxmlformats.org/officeDocument/2006/customXml" ds:itemID="{61E98C35-9ECE-4425-BCBA-00E118C705CE}">
+  <ds:schemaRefs>
+    <ds:schemaRef ds:uri="http://schemas.microsoft.com/office/2006/metadata/properties"/>
+    <ds:schemaRef ds:uri="http://www.w3.org/XML/1998/namespace"/>
+    <ds:schemaRef ds:uri="http://purl.org/dc/terms/"/>
+    <ds:schemaRef ds:uri="http://schemas.microsoft.com/office/2006/documentManagement/types"/>
+    <ds:schemaRef ds:uri="http://schemas.openxmlformats.org/package/2006/metadata/core-properties"/>
+    <ds:schemaRef ds:uri="http://schemas.microsoft.com/office/infopath/2007/PartnerControls"/>
+    <ds:schemaRef ds:uri="http://purl.org/dc/dcmitype/"/>
+    <ds:schemaRef ds:uri="b7af3e86-f9f2-49b9-954a-ad5c33749f37"/>
+    <ds:schemaRef ds:uri="http://purl.org/dc/elements/1.1/"/>
+  </ds:schemaRefs>
+</ds:datastoreItem>
 </file>
 
-<file path=customXml/itemProps1.xml><?xml version="1.0" encoding="utf-8"?>
+<file path=customXml/itemProps2.xml><?xml version="1.0" encoding="utf-8"?>
 <ds:datastoreItem xmlns:ds="http://schemas.openxmlformats.org/officeDocument/2006/customXml" ds:itemID="{45A8381C-73EB-48EA-B45F-7B7C8C7DF409}">
   <ds:schemaRefs>
     <ds:schemaRef ds:uri="http://schemas.microsoft.com/sharepoint/v3/contenttype/forms"/>
@@ -20151,7 +20170,7 @@
 </ds:datastoreItem>
 </file>
 
-<file path=customXml/itemProps2.xml><?xml version="1.0" encoding="utf-8"?>
+<file path=customXml/itemProps3.xml><?xml version="1.0" encoding="utf-8"?>
 <ds:datastoreItem xmlns:ds="http://schemas.openxmlformats.org/officeDocument/2006/customXml" ds:itemID="{0E7EEDD1-4774-4B18-AF2B-7A390A6B7ABD}">
   <ds:schemaRefs>
     <ds:schemaRef ds:uri="b7af3e86-f9f2-49b9-954a-ad5c33749f37"/>
@@ -20169,22 +20188,6 @@
 </ds:datastoreItem>
 </file>
 
-<file path=customXml/itemProps3.xml><?xml version="1.0" encoding="utf-8"?>
-<ds:datastoreItem xmlns:ds="http://schemas.openxmlformats.org/officeDocument/2006/customXml" ds:itemID="{61E98C35-9ECE-4425-BCBA-00E118C705CE}">
-  <ds:schemaRefs>
-    <ds:schemaRef ds:uri="http://schemas.microsoft.com/office/2006/metadata/properties"/>
-    <ds:schemaRef ds:uri="http://www.w3.org/XML/1998/namespace"/>
-    <ds:schemaRef ds:uri="http://purl.org/dc/terms/"/>
-    <ds:schemaRef ds:uri="http://schemas.microsoft.com/office/2006/documentManagement/types"/>
-    <ds:schemaRef ds:uri="http://schemas.openxmlformats.org/package/2006/metadata/core-properties"/>
-    <ds:schemaRef ds:uri="http://schemas.microsoft.com/office/infopath/2007/PartnerControls"/>
-    <ds:schemaRef ds:uri="http://purl.org/dc/dcmitype/"/>
-    <ds:schemaRef ds:uri="b7af3e86-f9f2-49b9-954a-ad5c33749f37"/>
-    <ds:schemaRef ds:uri="http://purl.org/dc/elements/1.1/"/>
-  </ds:schemaRefs>
-</ds:datastoreItem>
-</file>
-
 <file path=docMetadata/LabelInfo.xml><?xml version="1.0" encoding="utf-8"?>
 <clbl:labelList xmlns:clbl="http://schemas.microsoft.com/office/2020/mipLabelMetadata"/>
 </file>
</xml_diff>

<commit_message>
feat: Aktualisierung der Präsentations- und Architektur-Dokumentation
- Austausch der Präsentationsdatei `Mealo_Präsentation.pptx` zur Verbesserung der visuellen Darstellung.
- Aktualisierung des Architekturdiagramms `systemarchitecture.PNG`, um die Systemarchitektur klarer darzustellen und aktuelle Änderungen zu reflektieren.
</commit_message>
<xml_diff>
--- a/documentation/Mealo_Präsentation.pptx
+++ b/documentation/Mealo_Präsentation.pptx
@@ -274,7 +274,7 @@
             <a:pPr rtl="0"/>
             <a:fld id="{664C4DC0-9876-4E6F-9F41-5927D213A67E}" type="datetime1">
               <a:rPr lang="de-DE" smtClean="0"/>
-              <a:t>01.07.2025</a:t>
+              <a:t>03.07.2025</a:t>
             </a:fld>
             <a:endParaRPr lang="de-DE"/>
           </a:p>
@@ -456,7 +456,7 @@
             <a:pPr rtl="0"/>
             <a:fld id="{2C2EA0FA-C0C7-43B0-9915-13FE01CBAEE6}" type="datetime1">
               <a:rPr lang="de-DE" smtClean="0"/>
-              <a:t>01.07.2025</a:t>
+              <a:t>03.07.2025</a:t>
             </a:fld>
             <a:endParaRPr lang="de-DE"/>
           </a:p>
@@ -16327,6 +16327,53 @@
           </a:extLst>
         </p:spPr>
       </p:pic>
+      <p:pic>
+        <p:nvPicPr>
+          <p:cNvPr id="1028" name="Picture 4">
+            <a:extLst>
+              <a:ext uri="{FF2B5EF4-FFF2-40B4-BE49-F238E27FC236}">
+                <a16:creationId xmlns:a16="http://schemas.microsoft.com/office/drawing/2014/main" id="{86B0EF6B-456A-9402-0331-B530504E6536}"/>
+              </a:ext>
+            </a:extLst>
+          </p:cNvPr>
+          <p:cNvPicPr>
+            <a:picLocks noChangeAspect="1" noChangeArrowheads="1"/>
+          </p:cNvPicPr>
+          <p:nvPr/>
+        </p:nvPicPr>
+        <p:blipFill>
+          <a:blip r:embed="rId10">
+            <a:extLst>
+              <a:ext uri="{28A0092B-C50C-407E-A947-70E740481C1C}">
+                <a14:useLocalDpi xmlns:a14="http://schemas.microsoft.com/office/drawing/2010/main" val="0"/>
+              </a:ext>
+            </a:extLst>
+          </a:blip>
+          <a:srcRect/>
+          <a:stretch>
+            <a:fillRect/>
+          </a:stretch>
+        </p:blipFill>
+        <p:spPr bwMode="auto">
+          <a:xfrm>
+            <a:off x="8135910" y="5446926"/>
+            <a:ext cx="1371257" cy="372275"/>
+          </a:xfrm>
+          <a:prstGeom prst="rect">
+            <a:avLst/>
+          </a:prstGeom>
+          <a:noFill/>
+          <a:extLst>
+            <a:ext uri="{909E8E84-426E-40DD-AFC4-6F175D3DCCD1}">
+              <a14:hiddenFill xmlns:a14="http://schemas.microsoft.com/office/drawing/2010/main">
+                <a:solidFill>
+                  <a:srgbClr val="FFFFFF"/>
+                </a:solidFill>
+              </a14:hiddenFill>
+            </a:ext>
+          </a:extLst>
+        </p:spPr>
+      </p:pic>
     </p:spTree>
     <p:extLst>
       <p:ext uri="{BB962C8B-B14F-4D97-AF65-F5344CB8AC3E}">
@@ -19974,23 +20021,6 @@
 </file>
 
 <file path=customXml/item1.xml><?xml version="1.0" encoding="utf-8"?>
-<p:properties xmlns:p="http://schemas.microsoft.com/office/2006/metadata/properties" xmlns:xsi="http://www.w3.org/2001/XMLSchema-instance" xmlns:pc="http://schemas.microsoft.com/office/infopath/2007/PartnerControls">
-  <documentManagement>
-    <_activity xmlns="b7af3e86-f9f2-49b9-954a-ad5c33749f37" xsi:nil="true"/>
-  </documentManagement>
-</p:properties>
-</file>
-
-<file path=customXml/item2.xml><?xml version="1.0" encoding="utf-8"?>
-<?mso-contentType ?>
-<FormTemplates xmlns="http://schemas.microsoft.com/sharepoint/v3/contenttype/forms">
-  <Display>DocumentLibraryForm</Display>
-  <Edit>DocumentLibraryForm</Edit>
-  <New>DocumentLibraryForm</New>
-</FormTemplates>
-</file>
-
-<file path=customXml/item3.xml><?xml version="1.0" encoding="utf-8"?>
 <ct:contentTypeSchema xmlns:ct="http://schemas.microsoft.com/office/2006/metadata/contentType" xmlns:ma="http://schemas.microsoft.com/office/2006/metadata/properties/metaAttributes" ct:_="" ma:_="" ma:contentTypeName="Dokument" ma:contentTypeID="0x010100BC9111FB9E78DE45818A7A2ABBF8EDF5" ma:contentTypeVersion="6" ma:contentTypeDescription="Ein neues Dokument erstellen." ma:contentTypeScope="" ma:versionID="c45bf96cc1af40af3c8a90091e27dc3e">
   <xsd:schema xmlns:xsd="http://www.w3.org/2001/XMLSchema" xmlns:xs="http://www.w3.org/2001/XMLSchema" xmlns:p="http://schemas.microsoft.com/office/2006/metadata/properties" xmlns:ns3="b7af3e86-f9f2-49b9-954a-ad5c33749f37" targetNamespace="http://schemas.microsoft.com/office/2006/metadata/properties" ma:root="true" ma:fieldsID="0ffa99b0f2f1e6187cfe49a1cd52875f" ns3:_="">
     <xsd:import namespace="b7af3e86-f9f2-49b9-954a-ad5c33749f37"/>
@@ -20146,31 +20176,24 @@
 </ct:contentTypeSchema>
 </file>
 
-<file path=customXml/itemProps1.xml><?xml version="1.0" encoding="utf-8"?>
-<ds:datastoreItem xmlns:ds="http://schemas.openxmlformats.org/officeDocument/2006/customXml" ds:itemID="{61E98C35-9ECE-4425-BCBA-00E118C705CE}">
-  <ds:schemaRefs>
-    <ds:schemaRef ds:uri="http://schemas.microsoft.com/office/2006/metadata/properties"/>
-    <ds:schemaRef ds:uri="http://www.w3.org/XML/1998/namespace"/>
-    <ds:schemaRef ds:uri="http://purl.org/dc/terms/"/>
-    <ds:schemaRef ds:uri="http://schemas.microsoft.com/office/2006/documentManagement/types"/>
-    <ds:schemaRef ds:uri="http://schemas.openxmlformats.org/package/2006/metadata/core-properties"/>
-    <ds:schemaRef ds:uri="http://schemas.microsoft.com/office/infopath/2007/PartnerControls"/>
-    <ds:schemaRef ds:uri="http://purl.org/dc/dcmitype/"/>
-    <ds:schemaRef ds:uri="b7af3e86-f9f2-49b9-954a-ad5c33749f37"/>
-    <ds:schemaRef ds:uri="http://purl.org/dc/elements/1.1/"/>
-  </ds:schemaRefs>
-</ds:datastoreItem>
+<file path=customXml/item2.xml><?xml version="1.0" encoding="utf-8"?>
+<?mso-contentType ?>
+<FormTemplates xmlns="http://schemas.microsoft.com/sharepoint/v3/contenttype/forms">
+  <Display>DocumentLibraryForm</Display>
+  <Edit>DocumentLibraryForm</Edit>
+  <New>DocumentLibraryForm</New>
+</FormTemplates>
 </file>
 
-<file path=customXml/itemProps2.xml><?xml version="1.0" encoding="utf-8"?>
-<ds:datastoreItem xmlns:ds="http://schemas.openxmlformats.org/officeDocument/2006/customXml" ds:itemID="{45A8381C-73EB-48EA-B45F-7B7C8C7DF409}">
-  <ds:schemaRefs>
-    <ds:schemaRef ds:uri="http://schemas.microsoft.com/sharepoint/v3/contenttype/forms"/>
-  </ds:schemaRefs>
-</ds:datastoreItem>
+<file path=customXml/item3.xml><?xml version="1.0" encoding="utf-8"?>
+<p:properties xmlns:p="http://schemas.microsoft.com/office/2006/metadata/properties" xmlns:xsi="http://www.w3.org/2001/XMLSchema-instance" xmlns:pc="http://schemas.microsoft.com/office/infopath/2007/PartnerControls">
+  <documentManagement>
+    <_activity xmlns="b7af3e86-f9f2-49b9-954a-ad5c33749f37" xsi:nil="true"/>
+  </documentManagement>
+</p:properties>
 </file>
 
-<file path=customXml/itemProps3.xml><?xml version="1.0" encoding="utf-8"?>
+<file path=customXml/itemProps1.xml><?xml version="1.0" encoding="utf-8"?>
 <ds:datastoreItem xmlns:ds="http://schemas.openxmlformats.org/officeDocument/2006/customXml" ds:itemID="{0E7EEDD1-4774-4B18-AF2B-7A390A6B7ABD}">
   <ds:schemaRefs>
     <ds:schemaRef ds:uri="b7af3e86-f9f2-49b9-954a-ad5c33749f37"/>
@@ -20188,6 +20211,30 @@
 </ds:datastoreItem>
 </file>
 
+<file path=customXml/itemProps2.xml><?xml version="1.0" encoding="utf-8"?>
+<ds:datastoreItem xmlns:ds="http://schemas.openxmlformats.org/officeDocument/2006/customXml" ds:itemID="{45A8381C-73EB-48EA-B45F-7B7C8C7DF409}">
+  <ds:schemaRefs>
+    <ds:schemaRef ds:uri="http://schemas.microsoft.com/sharepoint/v3/contenttype/forms"/>
+  </ds:schemaRefs>
+</ds:datastoreItem>
+</file>
+
+<file path=customXml/itemProps3.xml><?xml version="1.0" encoding="utf-8"?>
+<ds:datastoreItem xmlns:ds="http://schemas.openxmlformats.org/officeDocument/2006/customXml" ds:itemID="{61E98C35-9ECE-4425-BCBA-00E118C705CE}">
+  <ds:schemaRefs>
+    <ds:schemaRef ds:uri="http://schemas.microsoft.com/office/2006/metadata/properties"/>
+    <ds:schemaRef ds:uri="http://www.w3.org/XML/1998/namespace"/>
+    <ds:schemaRef ds:uri="http://purl.org/dc/terms/"/>
+    <ds:schemaRef ds:uri="http://schemas.microsoft.com/office/2006/documentManagement/types"/>
+    <ds:schemaRef ds:uri="http://schemas.openxmlformats.org/package/2006/metadata/core-properties"/>
+    <ds:schemaRef ds:uri="http://schemas.microsoft.com/office/infopath/2007/PartnerControls"/>
+    <ds:schemaRef ds:uri="http://purl.org/dc/dcmitype/"/>
+    <ds:schemaRef ds:uri="b7af3e86-f9f2-49b9-954a-ad5c33749f37"/>
+    <ds:schemaRef ds:uri="http://purl.org/dc/elements/1.1/"/>
+  </ds:schemaRefs>
+</ds:datastoreItem>
+</file>
+
 <file path=docMetadata/LabelInfo.xml><?xml version="1.0" encoding="utf-8"?>
 <clbl:labelList xmlns:clbl="http://schemas.microsoft.com/office/2020/mipLabelMetadata"/>
 </file>
</xml_diff>